<commit_message>
Update workflow to show Boltz-2
</commit_message>
<xml_diff>
--- a/paper/workflow.pptx
+++ b/paper/workflow.pptx
@@ -5081,7 +5081,7 @@
           <a:p>
             <a:fld id="{659833EF-9F24-4392-9D9E-840CC6E30A15}" type="datetimeFigureOut">
               <a:rPr lang="en-US" smtClean="0"/>
-              <a:t>9/26/2025</a:t>
+              <a:t>2/19/2026</a:t>
             </a:fld>
             <a:endParaRPr lang="en-US"/>
           </a:p>
@@ -5251,7 +5251,7 @@
           <a:p>
             <a:fld id="{659833EF-9F24-4392-9D9E-840CC6E30A15}" type="datetimeFigureOut">
               <a:rPr lang="en-US" smtClean="0"/>
-              <a:t>9/26/2025</a:t>
+              <a:t>2/19/2026</a:t>
             </a:fld>
             <a:endParaRPr lang="en-US"/>
           </a:p>
@@ -5431,7 +5431,7 @@
           <a:p>
             <a:fld id="{659833EF-9F24-4392-9D9E-840CC6E30A15}" type="datetimeFigureOut">
               <a:rPr lang="en-US" smtClean="0"/>
-              <a:t>9/26/2025</a:t>
+              <a:t>2/19/2026</a:t>
             </a:fld>
             <a:endParaRPr lang="en-US"/>
           </a:p>
@@ -5601,7 +5601,7 @@
           <a:p>
             <a:fld id="{659833EF-9F24-4392-9D9E-840CC6E30A15}" type="datetimeFigureOut">
               <a:rPr lang="en-US" smtClean="0"/>
-              <a:t>9/26/2025</a:t>
+              <a:t>2/19/2026</a:t>
             </a:fld>
             <a:endParaRPr lang="en-US"/>
           </a:p>
@@ -5847,7 +5847,7 @@
           <a:p>
             <a:fld id="{659833EF-9F24-4392-9D9E-840CC6E30A15}" type="datetimeFigureOut">
               <a:rPr lang="en-US" smtClean="0"/>
-              <a:t>9/26/2025</a:t>
+              <a:t>2/19/2026</a:t>
             </a:fld>
             <a:endParaRPr lang="en-US"/>
           </a:p>
@@ -6079,7 +6079,7 @@
           <a:p>
             <a:fld id="{659833EF-9F24-4392-9D9E-840CC6E30A15}" type="datetimeFigureOut">
               <a:rPr lang="en-US" smtClean="0"/>
-              <a:t>9/26/2025</a:t>
+              <a:t>2/19/2026</a:t>
             </a:fld>
             <a:endParaRPr lang="en-US"/>
           </a:p>
@@ -6446,7 +6446,7 @@
           <a:p>
             <a:fld id="{659833EF-9F24-4392-9D9E-840CC6E30A15}" type="datetimeFigureOut">
               <a:rPr lang="en-US" smtClean="0"/>
-              <a:t>9/26/2025</a:t>
+              <a:t>2/19/2026</a:t>
             </a:fld>
             <a:endParaRPr lang="en-US"/>
           </a:p>
@@ -6564,7 +6564,7 @@
           <a:p>
             <a:fld id="{659833EF-9F24-4392-9D9E-840CC6E30A15}" type="datetimeFigureOut">
               <a:rPr lang="en-US" smtClean="0"/>
-              <a:t>9/26/2025</a:t>
+              <a:t>2/19/2026</a:t>
             </a:fld>
             <a:endParaRPr lang="en-US"/>
           </a:p>
@@ -6659,7 +6659,7 @@
           <a:p>
             <a:fld id="{659833EF-9F24-4392-9D9E-840CC6E30A15}" type="datetimeFigureOut">
               <a:rPr lang="en-US" smtClean="0"/>
-              <a:t>9/26/2025</a:t>
+              <a:t>2/19/2026</a:t>
             </a:fld>
             <a:endParaRPr lang="en-US"/>
           </a:p>
@@ -6936,7 +6936,7 @@
           <a:p>
             <a:fld id="{659833EF-9F24-4392-9D9E-840CC6E30A15}" type="datetimeFigureOut">
               <a:rPr lang="en-US" smtClean="0"/>
-              <a:t>9/26/2025</a:t>
+              <a:t>2/19/2026</a:t>
             </a:fld>
             <a:endParaRPr lang="en-US"/>
           </a:p>
@@ -7193,7 +7193,7 @@
           <a:p>
             <a:fld id="{659833EF-9F24-4392-9D9E-840CC6E30A15}" type="datetimeFigureOut">
               <a:rPr lang="en-US" smtClean="0"/>
-              <a:t>9/26/2025</a:t>
+              <a:t>2/19/2026</a:t>
             </a:fld>
             <a:endParaRPr lang="en-US"/>
           </a:p>
@@ -7406,7 +7406,7 @@
           <a:p>
             <a:fld id="{659833EF-9F24-4392-9D9E-840CC6E30A15}" type="datetimeFigureOut">
               <a:rPr lang="en-US" smtClean="0"/>
-              <a:t>9/26/2025</a:t>
+              <a:t>2/19/2026</a:t>
             </a:fld>
             <a:endParaRPr lang="en-US"/>
           </a:p>
@@ -8641,19 +8641,29 @@
                 <a:latin typeface="Arial" panose="020B0604020202020204" pitchFamily="34" charset="0"/>
                 <a:cs typeface="Arial" panose="020B0604020202020204" pitchFamily="34" charset="0"/>
               </a:rPr>
-              <a:t> sequence and antigen as a multimer with </a:t>
+              <a:t> sequence and antigen </a:t>
+            </a:r>
+            <a:r>
+              <a:rPr lang="en-US" sz="900" dirty="0">
+                <a:latin typeface="Arial" panose="020B0604020202020204" pitchFamily="34" charset="0"/>
+                <a:cs typeface="Arial" panose="020B0604020202020204" pitchFamily="34" charset="0"/>
+              </a:rPr>
+              <a:t>together</a:t>
+            </a:r>
+            <a:r>
+              <a:rPr lang="en-US" sz="900" kern="1200" dirty="0">
+                <a:latin typeface="Arial" panose="020B0604020202020204" pitchFamily="34" charset="0"/>
+                <a:cs typeface="Arial" panose="020B0604020202020204" pitchFamily="34" charset="0"/>
+              </a:rPr>
+              <a:t> with ESM3/</a:t>
             </a:r>
             <a:r>
               <a:rPr lang="en-US" sz="900" i="1" kern="1200" dirty="0">
                 <a:latin typeface="Arial" panose="020B0604020202020204" pitchFamily="34" charset="0"/>
                 <a:cs typeface="Arial" panose="020B0604020202020204" pitchFamily="34" charset="0"/>
               </a:rPr>
-              <a:t>ESM3</a:t>
+              <a:t>Boltz-2</a:t>
             </a:r>
-            <a:endParaRPr lang="en-US" sz="900" kern="1200" dirty="0">
-              <a:latin typeface="Arial" panose="020B0604020202020204" pitchFamily="34" charset="0"/>
-              <a:cs typeface="Arial" panose="020B0604020202020204" pitchFamily="34" charset="0"/>
-            </a:endParaRPr>
           </a:p>
         </p:txBody>
       </p:sp>

</xml_diff>